<commit_message>
Keine Kochboxen: Zutaten werden nach Rezeptkarte gesammelt
Sichtzone zeigt Rezeptkarten und ein Bild des Gerichts statt fertiger
Pakete; Pasta-Rückseite mit weiteren Sorten und Saucen; PowerPoint
Folie 10 angepasst.

Co-Authored-By: Claude Opus 5.5 <noreply@anthropic.com>
Claude-Session: https://claude.ai/code/session_015CHQQ8TNG8MYypZAXnuHE4
</commit_message>
<xml_diff>
--- a/praesentation/One_Hour_Kitchen_Store-Konzept_v2.pptx
+++ b/praesentation/One_Hour_Kitchen_Store-Konzept_v2.pptx
@@ -1291,7 +1291,7 @@
           <a:p>
             <a:r>
               <a:rPr lang="en-US" dirty="0"/>
-              <a:t>Das Regal der Pasta Night zeigt, wie der Präsenter im Laden weiterlebt. Jede Koje ist eine Spalte der Matrix, geteilt in günstig, besonders und schnell. Der Abschnitt schnell liegt am Regalkopf direkt am Hauptgang. Waagerecht bleiben die Regalzonen: oben die Anlass-Schilder, in der Sichtzone Rezeptkarten und Bundles, darunter die Zutaten. Kühlpflichtige Zutaten stehen nicht hier, dazu die nächste Folie.</a:t>
+              <a:t>Das Regal der Pasta Night zeigt, wie das Dashboard im Laden weiterlebt. Jede Koje ist eine Spalte der Matrix, geteilt in günstig, besonders und schnell. Der Abschnitt schnell liegt am Regalkopf direkt am Gang. Waagerecht bleiben die Regalzonen: oben die Anlass-Schilder, in der Sichtzone Rezeptkarten und ein Bild des Gerichts, darunter die Zutaten. Es gibt keine fertigen Pakete: Die Kundin sammelt die Zutaten selbst anhand ihrer Karte. Kühlpflichtige Zutaten stehen nicht hier, dazu die nächste Folie.</a:t>
             </a:r>
           </a:p>
         </p:txBody>
@@ -4394,7 +4394,7 @@
                 <a:ea typeface="Calibri" pitchFamily="34" charset="-122"/>
                 <a:cs typeface="Calibri" pitchFamily="34" charset="-120"/>
               </a:rPr>
-              <a:t>Karte #01 Creamy Tomato Pasta + Bundle für 2</a:t>
+              <a:t>Karte #01 Creamy Tomato Pasta</a:t>
             </a:r>
             <a:endParaRPr lang="en-US" sz="1100" dirty="0"/>
           </a:p>
@@ -5581,7 +5581,7 @@
                 <a:ea typeface="Calibri" pitchFamily="34" charset="-122"/>
                 <a:cs typeface="Calibri" pitchFamily="34" charset="-120"/>
               </a:rPr>
-              <a:t>Rezeptkarten und Bundles stehen dort, wo Ware am leichtesten gesehen wird; schwere Gebinde in der Bückzone.</a:t>
+              <a:t>Rezeptkarten und ein Bild des Gerichts stehen dort, wo am leichtesten gesehen wird; schwere Gebinde in der Bückzone.</a:t>
             </a:r>
             <a:endParaRPr lang="en-US" sz="1250" dirty="0"/>
           </a:p>

</xml_diff>

<commit_message>
Kochwelt-Regale klassisch nach Warengruppen (Produktblöcke)
Nudeln bei Nudeln, Saucen bei Saucen: senkrechte Produktblöcke mit
Fachcode-Schild und Rezepthinweis, Rezeptkarten am Regalkopf, Einkaufs-
Spiel findet Zutaten über den Block; PowerPoint Folien 9, 10, 13 angepasst.

Co-Authored-By: Claude Opus 5.5 <noreply@anthropic.com>
Claude-Session: https://claude.ai/code/session_015CHQQ8TNG8MYypZAXnuHE4
</commit_message>
<xml_diff>
--- a/praesentation/One_Hour_Kitchen_Store-Konzept_v2.pptx
+++ b/praesentation/One_Hour_Kitchen_Store-Konzept_v2.pptx
@@ -1291,7 +1291,7 @@
           <a:p>
             <a:r>
               <a:rPr lang="en-US" dirty="0"/>
-              <a:t>Das Regal der Pasta Night zeigt, wie das Dashboard im Laden weiterlebt. Jede Koje ist eine Spalte der Matrix, geteilt in günstig, besonders und schnell. Der Abschnitt schnell liegt am Regalkopf direkt am Gang. Waagerecht bleiben die Regalzonen: oben die Anlass-Schilder, in der Sichtzone Rezeptkarten und ein Bild des Gerichts, darunter die Zutaten. Es gibt keine fertigen Pakete: Die Kundin sammelt die Zutaten selbst anhand ihrer Karte. Kühlpflichtige Zutaten stehen nicht hier, dazu die nächste Folie.</a:t>
+              <a:t>Das Regal der Pasta Night ist aufgebaut wie im klassischen Supermarkt: Nudeln bei Nudeln, Saucen bei Saucen, Bohnen und Brühe daneben, jeweils als senkrechter Produktblock. Die Kundin sammelt die Zutaten selbst anhand ihrer Rezeptkarte: Fachcode W1 führt in die Koje, das Blockschild zeigt, für welche Rezepte der Block gebraucht wird. Standardgrößen in Sicht- und Greifzone, Großpackungen unten. Kühlpflichtige Zutaten stehen nicht hier, dazu die nächste Folie.</a:t>
             </a:r>
           </a:p>
         </p:txBody>
@@ -3677,7 +3677,7 @@
                 <a:ea typeface="Cambria" pitchFamily="34" charset="-122"/>
                 <a:cs typeface="Cambria" pitchFamily="34" charset="-120"/>
               </a:rPr>
-              <a:t>Regalbild Pasta Night: das Dashboard, im Regal gespiegelt.</a:t>
+              <a:t>Regalbild Pasta Night: klassisch nach Warengruppen.</a:t>
             </a:r>
             <a:endParaRPr lang="en-US" sz="2800" dirty="0"/>
           </a:p>
@@ -3983,7 +3983,7 @@
                 <a:ea typeface="Calibri" pitchFamily="34" charset="-122"/>
                 <a:cs typeface="Calibri" pitchFamily="34" charset="-120"/>
               </a:rPr>
-              <a:t>€  Für den kleinen Geldbeutel</a:t>
+              <a:t>W1 · Nudeln</a:t>
             </a:r>
             <a:endParaRPr lang="en-US" sz="1100" dirty="0"/>
           </a:p>
@@ -4054,7 +4054,7 @@
                 <a:ea typeface="Calibri" pitchFamily="34" charset="-122"/>
                 <a:cs typeface="Calibri" pitchFamily="34" charset="-120"/>
               </a:rPr>
-              <a:t>★  Für besondere Abende</a:t>
+              <a:t>W1 · Tomaten &amp; Saucen</a:t>
             </a:r>
             <a:endParaRPr lang="en-US" sz="1100" dirty="0"/>
           </a:p>
@@ -4125,7 +4125,7 @@
                 <a:ea typeface="Calibri" pitchFamily="34" charset="-122"/>
                 <a:cs typeface="Calibri" pitchFamily="34" charset="-120"/>
               </a:rPr>
-              <a:t>»  Wenn’s schnell gehen muss</a:t>
+              <a:t>W1 · Bohnen, Brühe &amp; Gewürze</a:t>
             </a:r>
             <a:endParaRPr lang="en-US" sz="1100" dirty="0"/>
           </a:p>
@@ -4252,7 +4252,7 @@
                 <a:ea typeface="Calibri" pitchFamily="34" charset="-122"/>
                 <a:cs typeface="Calibri" pitchFamily="34" charset="-120"/>
               </a:rPr>
-              <a:t>Karte #03 Pasta e Fagioli, 3,20 € je Portion</a:t>
+              <a:t>Spaghetti, Penne, Ditalini 500 g</a:t>
             </a:r>
             <a:endParaRPr lang="en-US" sz="1100" dirty="0"/>
           </a:p>
@@ -4323,7 +4323,7 @@
                 <a:ea typeface="Calibri" pitchFamily="34" charset="-122"/>
                 <a:cs typeface="Calibri" pitchFamily="34" charset="-120"/>
               </a:rPr>
-              <a:t>Karte #02 Tagliatelle al Limone</a:t>
+              <a:t>Sugo, Tomatensauce, Passata</a:t>
             </a:r>
             <a:endParaRPr lang="en-US" sz="1100" dirty="0"/>
           </a:p>
@@ -4394,7 +4394,7 @@
                 <a:ea typeface="Calibri" pitchFamily="34" charset="-122"/>
                 <a:cs typeface="Calibri" pitchFamily="34" charset="-120"/>
               </a:rPr>
-              <a:t>Karte #01 Creamy Tomato Pasta</a:t>
+              <a:t>Borlotti, Cannellini, Brühe</a:t>
             </a:r>
             <a:endParaRPr lang="en-US" sz="1100" dirty="0"/>
           </a:p>
@@ -4521,7 +4521,7 @@
                 <a:ea typeface="Calibri" pitchFamily="34" charset="-122"/>
                 <a:cs typeface="Calibri" pitchFamily="34" charset="-120"/>
               </a:rPr>
-              <a:t>Pasta, Bohnen, Passata</a:t>
+              <a:t>Tagliatelle, Fusilli</a:t>
             </a:r>
             <a:endParaRPr lang="en-US" sz="1100" dirty="0"/>
           </a:p>
@@ -4592,7 +4592,7 @@
                 <a:ea typeface="Calibri" pitchFamily="34" charset="-122"/>
                 <a:cs typeface="Calibri" pitchFamily="34" charset="-120"/>
               </a:rPr>
-              <a:t>Tagliatelle, Zitronen, Tiramisu-Set</a:t>
+              <a:t>Pomodori gehackt, Pesto</a:t>
             </a:r>
             <a:endParaRPr lang="en-US" sz="1100" dirty="0"/>
           </a:p>
@@ -4663,7 +4663,7 @@
                 <a:ea typeface="Calibri" pitchFamily="34" charset="-122"/>
                 <a:cs typeface="Calibri" pitchFamily="34" charset="-120"/>
               </a:rPr>
-              <a:t>Pasta, Tomatensauce, Gewürze</a:t>
+              <a:t>Pasta-Gewürz, Zitronenpfeffer</a:t>
             </a:r>
             <a:endParaRPr lang="en-US" sz="1100" dirty="0"/>
           </a:p>
@@ -4790,7 +4790,7 @@
                 <a:ea typeface="Calibri" pitchFamily="34" charset="-122"/>
                 <a:cs typeface="Calibri" pitchFamily="34" charset="-120"/>
               </a:rPr>
-              <a:t>Großpackungen Pasta und Bohnen</a:t>
+              <a:t>Spaghetti 1 kg, Ditalini 1 kg</a:t>
             </a:r>
             <a:endParaRPr lang="en-US" sz="1100" dirty="0"/>
           </a:p>
@@ -4861,7 +4861,7 @@
                 <a:ea typeface="Calibri" pitchFamily="34" charset="-122"/>
                 <a:cs typeface="Calibri" pitchFamily="34" charset="-120"/>
               </a:rPr>
-              <a:t>Aperitivo alkoholfrei, Limonade</a:t>
+              <a:t>Sugo 680 g, Passata 1 kg</a:t>
             </a:r>
             <a:endParaRPr lang="en-US" sz="1100" dirty="0"/>
           </a:p>
@@ -4932,7 +4932,7 @@
                 <a:ea typeface="Calibri" pitchFamily="34" charset="-122"/>
                 <a:cs typeface="Calibri" pitchFamily="34" charset="-120"/>
               </a:rPr>
-              <a:t>Wasser, Getränke im 6er-Pack</a:t>
+              <a:t>Borlotti 800 g</a:t>
             </a:r>
             <a:endParaRPr lang="en-US" sz="1100" dirty="0"/>
           </a:p>
@@ -4971,7 +4971,7 @@
                 <a:ea typeface="Calibri" pitchFamily="34" charset="-122"/>
                 <a:cs typeface="Calibri" pitchFamily="34" charset="-120"/>
               </a:rPr>
-              <a:t>€ günstig</a:t>
+              <a:t>Nudeln</a:t>
             </a:r>
             <a:endParaRPr lang="en-US" sz="1200" dirty="0"/>
           </a:p>
@@ -5010,7 +5010,7 @@
                 <a:ea typeface="Calibri" pitchFamily="34" charset="-122"/>
                 <a:cs typeface="Calibri" pitchFamily="34" charset="-120"/>
               </a:rPr>
-              <a:t>★ besonders</a:t>
+              <a:t>Saucen</a:t>
             </a:r>
             <a:endParaRPr lang="en-US" sz="1200" dirty="0"/>
           </a:p>
@@ -5049,7 +5049,7 @@
                 <a:ea typeface="Calibri" pitchFamily="34" charset="-122"/>
                 <a:cs typeface="Calibri" pitchFamily="34" charset="-120"/>
               </a:rPr>
-              <a:t>» schnell</a:t>
+              <a:t>Bohnen &amp; Brühe</a:t>
             </a:r>
             <a:endParaRPr lang="en-US" sz="1200" dirty="0"/>
           </a:p>
@@ -5088,7 +5088,7 @@
                 <a:ea typeface="Calibri" pitchFamily="34" charset="-122"/>
                 <a:cs typeface="Calibri" pitchFamily="34" charset="-120"/>
               </a:rPr>
-              <a:t>Hauptgang →</a:t>
+              <a:t>← Karten am Regalkopf</a:t>
             </a:r>
             <a:endParaRPr lang="en-US" sz="1100" dirty="0"/>
           </a:p>
@@ -5127,7 +5127,7 @@
                 <a:ea typeface="Calibri" pitchFamily="34" charset="-122"/>
                 <a:cs typeface="Calibri" pitchFamily="34" charset="-120"/>
               </a:rPr>
-              <a:t>vertikal: Anlass · horizontal: Funktion der Zone</a:t>
+              <a:t>vertikal: Warengruppe (Produktblock) · horizontal: Regalzone</a:t>
             </a:r>
             <a:endParaRPr lang="en-US" sz="1100" dirty="0"/>
           </a:p>
@@ -5166,7 +5166,7 @@
                 <a:ea typeface="Calibri" pitchFamily="34" charset="-122"/>
                 <a:cs typeface="Calibri" pitchFamily="34" charset="-120"/>
               </a:rPr>
-              <a:t>Gespiegelte Matrix</a:t>
+              <a:t>Klassische Ordnung</a:t>
             </a:r>
             <a:endParaRPr lang="en-US" sz="1500" dirty="0"/>
           </a:p>
@@ -5205,7 +5205,7 @@
                 <a:ea typeface="Calibri" pitchFamily="34" charset="-122"/>
                 <a:cs typeface="Calibri" pitchFamily="34" charset="-120"/>
               </a:rPr>
-              <a:t>Jede Koje ist eine Spalte des Dashboards: dieselben drei Anlässe, Symbole und Rezeptnummern. Wer am Eingang gewählt hat, findet sein Feld sofort wieder.</a:t>
+              <a:t>Pasta bei Pasta, Sauce bei Sauce: Die Kundin findet die Zutaten ihrer Rezeptkarte wie in jedem Supermarkt. Das Blockschild nennt, für welche Rezepte der Block gebraucht wird.</a:t>
             </a:r>
             <a:endParaRPr lang="en-US" sz="1250" dirty="0"/>
           </a:p>
@@ -5315,7 +5315,7 @@
                 <a:ea typeface="Calibri" pitchFamily="34" charset="-122"/>
                 <a:cs typeface="Calibri" pitchFamily="34" charset="-120"/>
               </a:rPr>
-              <a:t>Kreuzblock-Prinzip, S. 303</a:t>
+              <a:t>Produktblock, S. 303</a:t>
             </a:r>
             <a:endParaRPr lang="en-US" sz="1000" dirty="0"/>
           </a:p>
@@ -5354,7 +5354,7 @@
                 <a:ea typeface="Calibri" pitchFamily="34" charset="-122"/>
                 <a:cs typeface="Calibri" pitchFamily="34" charset="-120"/>
               </a:rPr>
-              <a:t>» schnell am Regalkopf</a:t>
+              <a:t>Rezeptkarten am Regalkopf</a:t>
             </a:r>
             <a:endParaRPr lang="en-US" sz="1500" dirty="0"/>
           </a:p>
@@ -5393,7 +5393,7 @@
                 <a:ea typeface="Calibri" pitchFamily="34" charset="-122"/>
                 <a:cs typeface="Calibri" pitchFamily="34" charset="-120"/>
               </a:rPr>
-              <a:t>Der Abschnitt für Eilige liegt direkt am Hauptgang. Wer schnell einkauft, muss nicht in die Koje hinein.</a:t>
+              <a:t>Am Gang stecken die Karten aller drei Rezepte der Kochwelt; der Fachcode W1 führt in diese Koje.</a:t>
             </a:r>
             <a:endParaRPr lang="en-US" sz="1250" dirty="0"/>
           </a:p>
@@ -5542,7 +5542,7 @@
                 <a:ea typeface="Calibri" pitchFamily="34" charset="-122"/>
                 <a:cs typeface="Calibri" pitchFamily="34" charset="-120"/>
               </a:rPr>
-              <a:t>Sichtzone für die Karte</a:t>
+              <a:t>Zonen nach Gewicht</a:t>
             </a:r>
             <a:endParaRPr lang="en-US" sz="1500" dirty="0"/>
           </a:p>
@@ -5581,7 +5581,7 @@
                 <a:ea typeface="Calibri" pitchFamily="34" charset="-122"/>
                 <a:cs typeface="Calibri" pitchFamily="34" charset="-120"/>
               </a:rPr>
-              <a:t>Rezeptkarten und ein Bild des Gerichts stehen dort, wo am leichtesten gesehen wird; schwere Gebinde in der Bückzone.</a:t>
+              <a:t>Standardgrößen in Sicht- und Greifzone, Großpackungen in der Bückzone.</a:t>
             </a:r>
             <a:endParaRPr lang="en-US" sz="1250" dirty="0"/>
           </a:p>
@@ -11259,7 +11259,7 @@
                 <a:ea typeface="Calibri" pitchFamily="34" charset="-122"/>
                 <a:cs typeface="Calibri" pitchFamily="34" charset="-120"/>
               </a:rPr>
-              <a:t>Koje, Spalte »</a:t>
+              <a:t>Koje per Fachcode</a:t>
             </a:r>
             <a:endParaRPr lang="en-US" sz="1800" dirty="0"/>
           </a:p>
@@ -31180,7 +31180,7 @@
                 <a:ea typeface="Calibri" pitchFamily="34" charset="-122"/>
                 <a:cs typeface="Calibri" pitchFamily="34" charset="-120"/>
               </a:rPr>
-              <a:t>Drei querstehende Gondeln bilden Kojen; jede ist eine Spalte des Dashboards.</a:t>
+              <a:t>Drei querstehende Gondeln bilden Kojen, je eine Kochwelt; innen nach Warengruppen sortiert.</a:t>
             </a:r>
             <a:endParaRPr lang="en-US" sz="1300" dirty="0"/>
           </a:p>

</xml_diff>

<commit_message>
Präsentation ersetzt PowerPoint; Regalzonen an allen Regalen
- Alle 19 PPTX-Folien als Folien im Modell (Karten, Diagramm, Matrix,
  Rezeptkarte, Parmesan-Regel, Begründungskette, Backup Fragerunde)
- Leiste mit Kapiteln, Timer 20:00, Sprechernotizen (N), Übersicht (O),
  Referentenansicht im zweiten Fenster (V), Vollbild (F), Clicker-Tasten
- Folien passen sich der Bildschirmgröße an
- Regalzonen-Bänder an allen Regalfronten, Belegung je Zone und Front,
  Zonentabelle in der Infokarte
- Parmesan-Fachcode K2 (Käse) auch in der PPTX korrigiert

Co-Authored-By: Claude Opus 5.5 <noreply@anthropic.com>
Claude-Session: https://claude.ai/code/session_015CHQQ8TNG8MYypZAXnuHE4
</commit_message>
<xml_diff>
--- a/praesentation/One_Hour_Kitchen_Store-Konzept_v2.pptx
+++ b/praesentation/One_Hour_Kitchen_Store-Konzept_v2.pptx
@@ -2079,10 +2079,10 @@
 – Gab es das nicht schon? Ja, das Kochhaus; wir haben neun Rezepte statt zwanzig, Basissortiment und sichtbare Küche (Folie 3).
 – Warum nicht HelloFresh? Die Box löst nächste Woche, wir lösen heute Abend (Folie 3).
 – Was heißt schnell, günstig, besonders? Höchstens 20 Minuten, höchstens 4 Euro pro Portion, Menü mit Dessert (Folie 12).
-– Parmesan in zwei Rezepten? Hauptplatzierung K3, Karten verweisen darauf (Folie 11).
+– Parmesan in zwei Rezepten? Hauptplatzierung K2 (Käse), Karten verweisen darauf (Folie 11).
 – Dienstagvormittag? Kursvorbereitung, ab 12 Uhr Live-Cooking (Folie 16).
 – Nur Milch? Schnellweg rechts, ca. 25 m (Folie 6).
-– Warum 150 m²? Kleiner würde die Showküche die Verkaufsfläche zu stark belasten (Folie 5).
+– Warum 190 m²? Kleiner würde die Showküche die Verkaufsfläche zu stark belasten (Folie 5).
 – Was ist belegt, was Annahme? Q- und A-Marken auf jeder Folie (Folie 18).</a:t>
             </a:r>
           </a:p>
@@ -6213,7 +6213,7 @@
                 <a:ea typeface="Calibri" pitchFamily="34" charset="-122"/>
                 <a:cs typeface="Calibri" pitchFamily="34" charset="-120"/>
               </a:rPr>
-              <a:t>Parmesan im Kühlregal Frische, Fach K3, Produktblock Käse</a:t>
+              <a:t>Parmesan im Kühlregal Frische, Fach K2, Produktblock Käse</a:t>
             </a:r>
             <a:endParaRPr lang="en-US" sz="1600" dirty="0"/>
           </a:p>
@@ -6314,7 +6314,7 @@
                 <a:ea typeface="Calibri" pitchFamily="34" charset="-122"/>
                 <a:cs typeface="Calibri" pitchFamily="34" charset="-120"/>
               </a:rPr>
-              <a:t>Karte verweist auf „K3“</a:t>
+              <a:t>Karte verweist auf „K2“</a:t>
             </a:r>
             <a:endParaRPr lang="en-US" sz="1200" dirty="0"/>
           </a:p>

</xml_diff>